<commit_message>
Move cached attributes into the Game object. Updates for the Web.
</commit_message>
<xml_diff>
--- a/Documents/Web Front-End Test Cases.pptx
+++ b/Documents/Web Front-End Test Cases.pptx
@@ -8,8 +8,12 @@
     <p:sldId id="283" r:id="rId2"/>
     <p:sldId id="286" r:id="rId3"/>
     <p:sldId id="287" r:id="rId4"/>
-    <p:sldId id="288" r:id="rId5"/>
+    <p:sldId id="291" r:id="rId5"/>
     <p:sldId id="289" r:id="rId6"/>
+    <p:sldId id="292" r:id="rId7"/>
+    <p:sldId id="288" r:id="rId8"/>
+    <p:sldId id="290" r:id="rId9"/>
+    <p:sldId id="293" r:id="rId10"/>
   </p:sldIdLst>
   <p:sldSz cx="12192000" cy="6858000"/>
   <p:notesSz cx="6858000" cy="9144000"/>
@@ -263,7 +267,7 @@
           <a:p>
             <a:fld id="{E7AEA4B1-7707-49BB-9265-EAC029350772}" type="datetimeFigureOut">
               <a:rPr lang="en-US" smtClean="0"/>
-              <a:t>6/22/2026</a:t>
+              <a:t>6/24/2026</a:t>
             </a:fld>
             <a:endParaRPr lang="en-US"/>
           </a:p>
@@ -461,7 +465,7 @@
           <a:p>
             <a:fld id="{E7AEA4B1-7707-49BB-9265-EAC029350772}" type="datetimeFigureOut">
               <a:rPr lang="en-US" smtClean="0"/>
-              <a:t>6/22/2026</a:t>
+              <a:t>6/24/2026</a:t>
             </a:fld>
             <a:endParaRPr lang="en-US"/>
           </a:p>
@@ -669,7 +673,7 @@
           <a:p>
             <a:fld id="{E7AEA4B1-7707-49BB-9265-EAC029350772}" type="datetimeFigureOut">
               <a:rPr lang="en-US" smtClean="0"/>
-              <a:t>6/22/2026</a:t>
+              <a:t>6/24/2026</a:t>
             </a:fld>
             <a:endParaRPr lang="en-US"/>
           </a:p>
@@ -867,7 +871,7 @@
           <a:p>
             <a:fld id="{E7AEA4B1-7707-49BB-9265-EAC029350772}" type="datetimeFigureOut">
               <a:rPr lang="en-US" smtClean="0"/>
-              <a:t>6/22/2026</a:t>
+              <a:t>6/24/2026</a:t>
             </a:fld>
             <a:endParaRPr lang="en-US"/>
           </a:p>
@@ -1142,7 +1146,7 @@
           <a:p>
             <a:fld id="{E7AEA4B1-7707-49BB-9265-EAC029350772}" type="datetimeFigureOut">
               <a:rPr lang="en-US" smtClean="0"/>
-              <a:t>6/22/2026</a:t>
+              <a:t>6/24/2026</a:t>
             </a:fld>
             <a:endParaRPr lang="en-US"/>
           </a:p>
@@ -1407,7 +1411,7 @@
           <a:p>
             <a:fld id="{E7AEA4B1-7707-49BB-9265-EAC029350772}" type="datetimeFigureOut">
               <a:rPr lang="en-US" smtClean="0"/>
-              <a:t>6/22/2026</a:t>
+              <a:t>6/24/2026</a:t>
             </a:fld>
             <a:endParaRPr lang="en-US"/>
           </a:p>
@@ -1819,7 +1823,7 @@
           <a:p>
             <a:fld id="{E7AEA4B1-7707-49BB-9265-EAC029350772}" type="datetimeFigureOut">
               <a:rPr lang="en-US" smtClean="0"/>
-              <a:t>6/22/2026</a:t>
+              <a:t>6/24/2026</a:t>
             </a:fld>
             <a:endParaRPr lang="en-US"/>
           </a:p>
@@ -1960,7 +1964,7 @@
           <a:p>
             <a:fld id="{E7AEA4B1-7707-49BB-9265-EAC029350772}" type="datetimeFigureOut">
               <a:rPr lang="en-US" smtClean="0"/>
-              <a:t>6/22/2026</a:t>
+              <a:t>6/24/2026</a:t>
             </a:fld>
             <a:endParaRPr lang="en-US"/>
           </a:p>
@@ -2073,7 +2077,7 @@
           <a:p>
             <a:fld id="{E7AEA4B1-7707-49BB-9265-EAC029350772}" type="datetimeFigureOut">
               <a:rPr lang="en-US" smtClean="0"/>
-              <a:t>6/22/2026</a:t>
+              <a:t>6/24/2026</a:t>
             </a:fld>
             <a:endParaRPr lang="en-US"/>
           </a:p>
@@ -2384,7 +2388,7 @@
           <a:p>
             <a:fld id="{E7AEA4B1-7707-49BB-9265-EAC029350772}" type="datetimeFigureOut">
               <a:rPr lang="en-US" smtClean="0"/>
-              <a:t>6/22/2026</a:t>
+              <a:t>6/24/2026</a:t>
             </a:fld>
             <a:endParaRPr lang="en-US"/>
           </a:p>
@@ -2672,7 +2676,7 @@
           <a:p>
             <a:fld id="{E7AEA4B1-7707-49BB-9265-EAC029350772}" type="datetimeFigureOut">
               <a:rPr lang="en-US" smtClean="0"/>
-              <a:t>6/22/2026</a:t>
+              <a:t>6/24/2026</a:t>
             </a:fld>
             <a:endParaRPr lang="en-US"/>
           </a:p>
@@ -2913,7 +2917,7 @@
           <a:p>
             <a:fld id="{E7AEA4B1-7707-49BB-9265-EAC029350772}" type="datetimeFigureOut">
               <a:rPr lang="en-US" smtClean="0"/>
-              <a:t>6/22/2026</a:t>
+              <a:t>6/24/2026</a:t>
             </a:fld>
             <a:endParaRPr lang="en-US"/>
           </a:p>
@@ -3461,7 +3465,7 @@
             <p:ph idx="1"/>
             <p:extLst>
               <p:ext uri="{D42A27DB-BD31-4B8C-83A1-F6EECF244321}">
-                <p14:modId xmlns:p14="http://schemas.microsoft.com/office/powerpoint/2010/main" val="3367317057"/>
+                <p14:modId xmlns:p14="http://schemas.microsoft.com/office/powerpoint/2010/main" val="1168489393"/>
               </p:ext>
             </p:extLst>
           </p:nvPr>
@@ -3867,17 +3871,33 @@
             <p:ph idx="1"/>
           </p:nvPr>
         </p:nvSpPr>
-        <p:spPr/>
-        <p:txBody>
-          <a:bodyPr/>
-          <a:lstStyle/>
+        <p:spPr>
+          <a:xfrm>
+            <a:off x="838200" y="1851103"/>
+            <a:ext cx="10515600" cy="4236650"/>
+          </a:xfrm>
+        </p:spPr>
+        <p:txBody>
+          <a:bodyPr>
+            <a:normAutofit/>
+          </a:bodyPr>
+          <a:lstStyle/>
+          <a:p>
+            <a:pPr marL="0" indent="0">
+              <a:buNone/>
+            </a:pPr>
+            <a:r>
+              <a:rPr lang="en-US" sz="2000" dirty="0"/>
+              <a:t>Steps</a:t>
+            </a:r>
+          </a:p>
           <a:p>
             <a:pPr marL="514350" indent="-514350">
               <a:buFont typeface="+mj-lt"/>
               <a:buAutoNum type="arabicPeriod"/>
             </a:pPr>
             <a:r>
-              <a:rPr lang="en-US" dirty="0"/>
+              <a:rPr lang="en-US" sz="2000" dirty="0"/>
               <a:t>Press Play New Game button</a:t>
             </a:r>
           </a:p>
@@ -3887,7 +3907,7 @@
               <a:buAutoNum type="arabicPeriod"/>
             </a:pPr>
             <a:r>
-              <a:rPr lang="en-US" dirty="0"/>
+              <a:rPr lang="en-US" sz="2000" dirty="0"/>
               <a:t>Save Game</a:t>
             </a:r>
           </a:p>
@@ -3897,7 +3917,7 @@
               <a:buAutoNum type="arabicPeriod"/>
             </a:pPr>
             <a:r>
-              <a:rPr lang="en-US" dirty="0"/>
+              <a:rPr lang="en-US" sz="2000" dirty="0"/>
               <a:t>Browser returns to home screen</a:t>
             </a:r>
           </a:p>
@@ -3907,9 +3927,67 @@
               <a:buAutoNum type="arabicPeriod"/>
             </a:pPr>
             <a:r>
-              <a:rPr lang="en-US" dirty="0"/>
+              <a:rPr lang="en-US" sz="2000" dirty="0"/>
               <a:t>Game and correct details appear under "Your Saved Games"</a:t>
             </a:r>
+          </a:p>
+          <a:p>
+            <a:pPr marL="514350" indent="-514350">
+              <a:buFont typeface="+mj-lt"/>
+              <a:buAutoNum type="arabicPeriod"/>
+            </a:pPr>
+            <a:endParaRPr lang="en-US" sz="2000" dirty="0"/>
+          </a:p>
+          <a:p>
+            <a:pPr marL="0" indent="0">
+              <a:buNone/>
+            </a:pPr>
+            <a:r>
+              <a:rPr lang="en-US" sz="2000" dirty="0"/>
+              <a:t>Components Tested</a:t>
+            </a:r>
+          </a:p>
+          <a:p>
+            <a:pPr marL="514350" indent="-514350">
+              <a:buFont typeface="+mj-lt"/>
+              <a:buAutoNum type="alphaLcParenR"/>
+            </a:pPr>
+            <a:r>
+              <a:rPr lang="en-US" sz="2000" dirty="0" err="1"/>
+              <a:t>PlayNewGameRunContext</a:t>
+            </a:r>
+            <a:endParaRPr lang="en-US" sz="2000" dirty="0"/>
+          </a:p>
+          <a:p>
+            <a:pPr marL="514350" indent="-514350">
+              <a:buFont typeface="+mj-lt"/>
+              <a:buAutoNum type="alphaLcParenR"/>
+            </a:pPr>
+            <a:r>
+              <a:rPr lang="en-US" sz="2000" dirty="0"/>
+              <a:t>Serialization</a:t>
+            </a:r>
+          </a:p>
+          <a:p>
+            <a:pPr marL="514350" indent="-514350">
+              <a:buFont typeface="+mj-lt"/>
+              <a:buAutoNum type="alphaLcParenR"/>
+            </a:pPr>
+            <a:r>
+              <a:rPr lang="en-US" sz="2000" dirty="0" err="1"/>
+              <a:t>SqlWebPersistent.WriteGame</a:t>
+            </a:r>
+            <a:r>
+              <a:rPr lang="en-US" sz="2000" dirty="0"/>
+              <a:t> for new game</a:t>
+            </a:r>
+          </a:p>
+          <a:p>
+            <a:pPr marL="514350" indent="-514350">
+              <a:buFont typeface="+mj-lt"/>
+              <a:buAutoNum type="arabicPeriod"/>
+            </a:pPr>
+            <a:endParaRPr lang="en-US" sz="2000" dirty="0"/>
           </a:p>
         </p:txBody>
       </p:sp>
@@ -3934,7 +4012,7 @@
         <p:cNvPr id="1" name="">
           <a:extLst>
             <a:ext uri="{FF2B5EF4-FFF2-40B4-BE49-F238E27FC236}">
-              <a16:creationId xmlns:a16="http://schemas.microsoft.com/office/drawing/2014/main" id="{F2A6E33D-EAF3-878B-A2B2-8512ECE07212}"/>
+              <a16:creationId xmlns:a16="http://schemas.microsoft.com/office/drawing/2014/main" id="{B79A8B13-AC64-D55B-3E37-61545161D9A2}"/>
             </a:ext>
           </a:extLst>
         </p:cNvPr>
@@ -3954,7 +4032,7 @@
           <p:cNvPr id="2" name="Title 1">
             <a:extLst>
               <a:ext uri="{FF2B5EF4-FFF2-40B4-BE49-F238E27FC236}">
-                <a16:creationId xmlns:a16="http://schemas.microsoft.com/office/drawing/2014/main" id="{2F7D14B3-B19E-7F71-3943-9C47CB3B3907}"/>
+                <a16:creationId xmlns:a16="http://schemas.microsoft.com/office/drawing/2014/main" id="{9E38EBAA-A44E-78F2-DF9B-C6DFC7BC5EA4}"/>
               </a:ext>
             </a:extLst>
           </p:cNvPr>
@@ -3972,7 +4050,7 @@
           <a:p>
             <a:r>
               <a:rPr lang="en-US" dirty="0"/>
-              <a:t>New Game</a:t>
+              <a:t>Aborted New Game</a:t>
             </a:r>
           </a:p>
         </p:txBody>
@@ -3982,7 +4060,7 @@
           <p:cNvPr id="3" name="Content Placeholder 2">
             <a:extLst>
               <a:ext uri="{FF2B5EF4-FFF2-40B4-BE49-F238E27FC236}">
-                <a16:creationId xmlns:a16="http://schemas.microsoft.com/office/drawing/2014/main" id="{E1D6F4BB-036B-6BFF-631C-9ECCD150CE3C}"/>
+                <a16:creationId xmlns:a16="http://schemas.microsoft.com/office/drawing/2014/main" id="{F05824FA-AA4E-2749-2776-EF3F2C9F4562}"/>
               </a:ext>
             </a:extLst>
           </p:cNvPr>
@@ -3995,16 +4073,27 @@
         </p:nvSpPr>
         <p:spPr/>
         <p:txBody>
-          <a:bodyPr/>
-          <a:lstStyle/>
+          <a:bodyPr>
+            <a:normAutofit/>
+          </a:bodyPr>
+          <a:lstStyle/>
+          <a:p>
+            <a:pPr marL="0" indent="0">
+              <a:buNone/>
+            </a:pPr>
+            <a:r>
+              <a:rPr lang="en-US" sz="2000" dirty="0"/>
+              <a:t>Steps</a:t>
+            </a:r>
+          </a:p>
           <a:p>
             <a:pPr marL="514350" indent="-514350">
               <a:buFont typeface="+mj-lt"/>
               <a:buAutoNum type="arabicPeriod"/>
             </a:pPr>
             <a:r>
-              <a:rPr lang="en-US" dirty="0"/>
-              <a:t>Press Play New Game button</a:t>
+              <a:rPr lang="en-US" sz="2000" dirty="0"/>
+              <a:t>Play new game</a:t>
             </a:r>
           </a:p>
           <a:p>
@@ -4013,9 +4102,14 @@
               <a:buAutoNum type="arabicPeriod"/>
             </a:pPr>
             <a:r>
-              <a:rPr lang="en-US" dirty="0"/>
-              <a:t>Save Game</a:t>
-            </a:r>
+              <a:rPr lang="en-US" sz="2000" dirty="0"/>
+              <a:t>Leave </a:t>
+            </a:r>
+            <a:r>
+              <a:rPr lang="en-US" sz="2000" dirty="0" err="1"/>
+              <a:t>play.ts</a:t>
+            </a:r>
+            <a:endParaRPr lang="en-US" sz="2000" dirty="0"/>
           </a:p>
           <a:p>
             <a:pPr marL="514350" indent="-514350">
@@ -4023,8 +4117,8 @@
               <a:buAutoNum type="arabicPeriod"/>
             </a:pPr>
             <a:r>
-              <a:rPr lang="en-US" dirty="0"/>
-              <a:t>Browser returns to home screen</a:t>
+              <a:rPr lang="en-US" sz="2000" dirty="0"/>
+              <a:t>Ensure game saves automatically</a:t>
             </a:r>
           </a:p>
           <a:p>
@@ -4033,16 +4127,48 @@
               <a:buAutoNum type="arabicPeriod"/>
             </a:pPr>
             <a:r>
-              <a:rPr lang="en-US" dirty="0"/>
-              <a:t>Game and correct details appear under "Your Saved Games"</a:t>
-            </a:r>
+              <a:rPr lang="en-US" sz="2000" dirty="0"/>
+              <a:t>Ensure replay appears</a:t>
+            </a:r>
+          </a:p>
+          <a:p>
+            <a:pPr marL="0" indent="0">
+              <a:buNone/>
+            </a:pPr>
+            <a:endParaRPr lang="en-US" sz="2000" dirty="0"/>
+          </a:p>
+          <a:p>
+            <a:pPr marL="0" indent="0">
+              <a:buNone/>
+            </a:pPr>
+            <a:r>
+              <a:rPr lang="en-US" sz="2000" dirty="0"/>
+              <a:t>Components</a:t>
+            </a:r>
+          </a:p>
+          <a:p>
+            <a:pPr marL="514350" indent="-514350">
+              <a:buFont typeface="+mj-lt"/>
+              <a:buAutoNum type="alphaLcParenR"/>
+            </a:pPr>
+            <a:r>
+              <a:rPr lang="en-US" sz="2000" dirty="0"/>
+              <a:t>Component </a:t>
+            </a:r>
+          </a:p>
+          <a:p>
+            <a:pPr marL="514350" indent="-514350">
+              <a:buFont typeface="+mj-lt"/>
+              <a:buAutoNum type="arabicPeriod"/>
+            </a:pPr>
+            <a:endParaRPr lang="en-US" sz="2000" dirty="0"/>
           </a:p>
         </p:txBody>
       </p:sp>
     </p:spTree>
     <p:extLst>
       <p:ext uri="{BB962C8B-B14F-4D97-AF65-F5344CB8AC3E}">
-        <p14:creationId xmlns:p14="http://schemas.microsoft.com/office/powerpoint/2010/main" val="4120375730"/>
+        <p14:creationId xmlns:p14="http://schemas.microsoft.com/office/powerpoint/2010/main" val="2137940485"/>
       </p:ext>
     </p:extLst>
   </p:cSld>
@@ -4121,15 +4247,26 @@
         </p:nvSpPr>
         <p:spPr/>
         <p:txBody>
-          <a:bodyPr/>
-          <a:lstStyle/>
+          <a:bodyPr>
+            <a:normAutofit fontScale="85000" lnSpcReduction="20000"/>
+          </a:bodyPr>
+          <a:lstStyle/>
+          <a:p>
+            <a:pPr marL="0" indent="0">
+              <a:buNone/>
+            </a:pPr>
+            <a:r>
+              <a:rPr lang="en-US" sz="2000" dirty="0"/>
+              <a:t>Steps</a:t>
+            </a:r>
+          </a:p>
           <a:p>
             <a:pPr marL="514350" indent="-514350">
               <a:buFont typeface="+mj-lt"/>
               <a:buAutoNum type="arabicPeriod"/>
             </a:pPr>
             <a:r>
-              <a:rPr lang="en-US" dirty="0"/>
+              <a:rPr lang="en-US" sz="2000" dirty="0"/>
               <a:t>Press Play This Game button</a:t>
             </a:r>
           </a:p>
@@ -4139,7 +4276,7 @@
               <a:buAutoNum type="arabicPeriod"/>
             </a:pPr>
             <a:r>
-              <a:rPr lang="en-US" dirty="0"/>
+              <a:rPr lang="en-US" sz="2000" dirty="0"/>
               <a:t>Save Game</a:t>
             </a:r>
           </a:p>
@@ -4149,7 +4286,7 @@
               <a:buAutoNum type="arabicPeriod"/>
             </a:pPr>
             <a:r>
-              <a:rPr lang="en-US" dirty="0"/>
+              <a:rPr lang="en-US" sz="2000" dirty="0"/>
               <a:t>Browser returns to home screen</a:t>
             </a:r>
           </a:p>
@@ -4159,7 +4296,7 @@
               <a:buAutoNum type="arabicPeriod"/>
             </a:pPr>
             <a:r>
-              <a:rPr lang="en-US" dirty="0"/>
+              <a:rPr lang="en-US" sz="2000" dirty="0"/>
               <a:t>Game and correct details appear under "Your Saved Games"</a:t>
             </a:r>
           </a:p>
@@ -4169,18 +4306,101 @@
               <a:buAutoNum type="arabicPeriod"/>
             </a:pPr>
             <a:r>
-              <a:rPr lang="en-US" dirty="0" err="1"/>
+              <a:rPr lang="en-US" sz="2000" dirty="0" err="1"/>
               <a:t>SavedGameContents</a:t>
             </a:r>
             <a:r>
-              <a:rPr lang="en-US" dirty="0"/>
-              <a:t> reflects new saved game.  Old game is deleted and </a:t>
-            </a:r>
-            <a:r>
-              <a:rPr lang="en-US"/>
-              <a:t>not orphaned.</a:t>
-            </a:r>
-            <a:endParaRPr lang="en-US" dirty="0"/>
+              <a:rPr lang="en-US" sz="2000" dirty="0"/>
+              <a:t> reflects new saved game.  Old game is deleted and not orphaned.</a:t>
+            </a:r>
+          </a:p>
+          <a:p>
+            <a:pPr marL="514350" indent="-514350">
+              <a:buFont typeface="+mj-lt"/>
+              <a:buAutoNum type="arabicPeriod"/>
+            </a:pPr>
+            <a:r>
+              <a:rPr lang="en-US" sz="2000" dirty="0"/>
+              <a:t>Press Play This Game button again, ensure game loads</a:t>
+            </a:r>
+          </a:p>
+          <a:p>
+            <a:pPr marL="514350" indent="-514350">
+              <a:buFont typeface="+mj-lt"/>
+              <a:buAutoNum type="arabicPeriod"/>
+            </a:pPr>
+            <a:r>
+              <a:rPr lang="en-US" sz="2000" dirty="0"/>
+              <a:t>Press Watch This Game button, ensure replay steps are accurate</a:t>
+            </a:r>
+          </a:p>
+          <a:p>
+            <a:pPr marL="514350" indent="-514350">
+              <a:buFont typeface="+mj-lt"/>
+              <a:buAutoNum type="arabicPeriod"/>
+            </a:pPr>
+            <a:endParaRPr lang="en-US" sz="2000" dirty="0"/>
+          </a:p>
+          <a:p>
+            <a:pPr marL="0" indent="0">
+              <a:buNone/>
+            </a:pPr>
+            <a:r>
+              <a:rPr lang="en-US" sz="2000" dirty="0"/>
+              <a:t>Components</a:t>
+            </a:r>
+          </a:p>
+          <a:p>
+            <a:pPr marL="514350" indent="-514350">
+              <a:buFont typeface="+mj-lt"/>
+              <a:buAutoNum type="alphaLcParenR"/>
+            </a:pPr>
+            <a:r>
+              <a:rPr lang="en-US" sz="2000" dirty="0" err="1"/>
+              <a:t>PlayExistingGameRunContext</a:t>
+            </a:r>
+            <a:endParaRPr lang="en-US" sz="2000" dirty="0"/>
+          </a:p>
+          <a:p>
+            <a:pPr marL="514350" indent="-514350">
+              <a:buFont typeface="+mj-lt"/>
+              <a:buAutoNum type="alphaLcParenR"/>
+            </a:pPr>
+            <a:r>
+              <a:rPr lang="en-US" sz="2000" dirty="0"/>
+              <a:t>Deserialization</a:t>
+            </a:r>
+          </a:p>
+          <a:p>
+            <a:pPr marL="514350" indent="-514350">
+              <a:buFont typeface="+mj-lt"/>
+              <a:buAutoNum type="alphaLcParenR"/>
+            </a:pPr>
+            <a:r>
+              <a:rPr lang="en-US" sz="2000" dirty="0" err="1"/>
+              <a:t>SqlWebPersistence.WriteGame</a:t>
+            </a:r>
+            <a:r>
+              <a:rPr lang="en-US" sz="2000" dirty="0"/>
+              <a:t> for modification</a:t>
+            </a:r>
+          </a:p>
+          <a:p>
+            <a:pPr marL="514350" indent="-514350">
+              <a:buFont typeface="+mj-lt"/>
+              <a:buAutoNum type="alphaLcParenR"/>
+            </a:pPr>
+            <a:r>
+              <a:rPr lang="en-US" sz="2000" dirty="0"/>
+              <a:t>Replay steps are appended accordingly</a:t>
+            </a:r>
+          </a:p>
+          <a:p>
+            <a:pPr marL="514350" indent="-514350">
+              <a:buFont typeface="+mj-lt"/>
+              <a:buAutoNum type="arabicPeriod"/>
+            </a:pPr>
+            <a:endParaRPr lang="en-US" sz="2000" dirty="0"/>
           </a:p>
         </p:txBody>
       </p:sp>
@@ -4188,6 +4408,666 @@
     <p:extLst>
       <p:ext uri="{BB962C8B-B14F-4D97-AF65-F5344CB8AC3E}">
         <p14:creationId xmlns:p14="http://schemas.microsoft.com/office/powerpoint/2010/main" val="2291882503"/>
+      </p:ext>
+    </p:extLst>
+  </p:cSld>
+  <p:clrMapOvr>
+    <a:masterClrMapping/>
+  </p:clrMapOvr>
+</p:sld>
+</file>
+
+<file path=ppt/slides/slide6.xml><?xml version="1.0" encoding="utf-8"?>
+<p:sld xmlns:a="http://schemas.openxmlformats.org/drawingml/2006/main" xmlns:r="http://schemas.openxmlformats.org/officeDocument/2006/relationships" xmlns:p="http://schemas.openxmlformats.org/presentationml/2006/main">
+  <p:cSld>
+    <p:spTree>
+      <p:nvGrpSpPr>
+        <p:cNvPr id="1" name="">
+          <a:extLst>
+            <a:ext uri="{FF2B5EF4-FFF2-40B4-BE49-F238E27FC236}">
+              <a16:creationId xmlns:a16="http://schemas.microsoft.com/office/drawing/2014/main" id="{8402B625-EFBC-27B7-1DB1-5750C773ED86}"/>
+            </a:ext>
+          </a:extLst>
+        </p:cNvPr>
+        <p:cNvGrpSpPr/>
+        <p:nvPr/>
+      </p:nvGrpSpPr>
+      <p:grpSpPr>
+        <a:xfrm>
+          <a:off x="0" y="0"/>
+          <a:ext cx="0" cy="0"/>
+          <a:chOff x="0" y="0"/>
+          <a:chExt cx="0" cy="0"/>
+        </a:xfrm>
+      </p:grpSpPr>
+      <p:sp>
+        <p:nvSpPr>
+          <p:cNvPr id="2" name="Title 1">
+            <a:extLst>
+              <a:ext uri="{FF2B5EF4-FFF2-40B4-BE49-F238E27FC236}">
+                <a16:creationId xmlns:a16="http://schemas.microsoft.com/office/drawing/2014/main" id="{BE577AEE-CDF9-4A71-7FF6-FFBE9311B1ED}"/>
+              </a:ext>
+            </a:extLst>
+          </p:cNvPr>
+          <p:cNvSpPr>
+            <a:spLocks noGrp="1"/>
+          </p:cNvSpPr>
+          <p:nvPr>
+            <p:ph type="title"/>
+          </p:nvPr>
+        </p:nvSpPr>
+        <p:spPr/>
+        <p:txBody>
+          <a:bodyPr/>
+          <a:lstStyle/>
+          <a:p>
+            <a:r>
+              <a:rPr lang="en-US" dirty="0"/>
+              <a:t>Abort Existing Game</a:t>
+            </a:r>
+          </a:p>
+        </p:txBody>
+      </p:sp>
+      <p:sp>
+        <p:nvSpPr>
+          <p:cNvPr id="3" name="Content Placeholder 2">
+            <a:extLst>
+              <a:ext uri="{FF2B5EF4-FFF2-40B4-BE49-F238E27FC236}">
+                <a16:creationId xmlns:a16="http://schemas.microsoft.com/office/drawing/2014/main" id="{57241E81-006A-895D-17D8-05FBD19A939F}"/>
+              </a:ext>
+            </a:extLst>
+          </p:cNvPr>
+          <p:cNvSpPr>
+            <a:spLocks noGrp="1"/>
+          </p:cNvSpPr>
+          <p:nvPr>
+            <p:ph idx="1"/>
+          </p:nvPr>
+        </p:nvSpPr>
+        <p:spPr/>
+        <p:txBody>
+          <a:bodyPr>
+            <a:normAutofit/>
+          </a:bodyPr>
+          <a:lstStyle/>
+          <a:p>
+            <a:pPr marL="0" indent="0">
+              <a:buNone/>
+            </a:pPr>
+            <a:r>
+              <a:rPr lang="en-US" sz="2000" dirty="0"/>
+              <a:t>Steps</a:t>
+            </a:r>
+          </a:p>
+          <a:p>
+            <a:pPr marL="514350" indent="-514350">
+              <a:buFont typeface="+mj-lt"/>
+              <a:buAutoNum type="arabicPeriod"/>
+            </a:pPr>
+            <a:r>
+              <a:rPr lang="en-US" sz="2000" dirty="0"/>
+              <a:t>Play existing game</a:t>
+            </a:r>
+          </a:p>
+          <a:p>
+            <a:pPr marL="514350" indent="-514350">
+              <a:buFont typeface="+mj-lt"/>
+              <a:buAutoNum type="arabicPeriod"/>
+            </a:pPr>
+            <a:r>
+              <a:rPr lang="en-US" sz="2000" dirty="0"/>
+              <a:t>Leave </a:t>
+            </a:r>
+            <a:r>
+              <a:rPr lang="en-US" sz="2000" dirty="0" err="1"/>
+              <a:t>play.ts</a:t>
+            </a:r>
+            <a:endParaRPr lang="en-US" sz="2000" dirty="0"/>
+          </a:p>
+          <a:p>
+            <a:pPr marL="514350" indent="-514350">
+              <a:buFont typeface="+mj-lt"/>
+              <a:buAutoNum type="arabicPeriod"/>
+            </a:pPr>
+            <a:r>
+              <a:rPr lang="en-US" sz="2000" dirty="0"/>
+              <a:t>Ensure game saves</a:t>
+            </a:r>
+          </a:p>
+          <a:p>
+            <a:pPr marL="514350" indent="-514350">
+              <a:buFont typeface="+mj-lt"/>
+              <a:buAutoNum type="arabicPeriod"/>
+            </a:pPr>
+            <a:r>
+              <a:rPr lang="en-US" sz="2000" dirty="0"/>
+              <a:t>Ensure replay valid</a:t>
+            </a:r>
+          </a:p>
+          <a:p>
+            <a:pPr marL="0" indent="0">
+              <a:buNone/>
+            </a:pPr>
+            <a:endParaRPr lang="en-US" sz="2000" dirty="0"/>
+          </a:p>
+          <a:p>
+            <a:pPr marL="0" indent="0">
+              <a:buNone/>
+            </a:pPr>
+            <a:r>
+              <a:rPr lang="en-US" sz="2000" dirty="0"/>
+              <a:t>Components</a:t>
+            </a:r>
+          </a:p>
+          <a:p>
+            <a:pPr marL="514350" indent="-514350">
+              <a:buFont typeface="+mj-lt"/>
+              <a:buAutoNum type="alphaLcParenR"/>
+            </a:pPr>
+            <a:r>
+              <a:rPr lang="en-US" sz="2000" dirty="0"/>
+              <a:t>Component </a:t>
+            </a:r>
+          </a:p>
+          <a:p>
+            <a:pPr marL="514350" indent="-514350">
+              <a:buFont typeface="+mj-lt"/>
+              <a:buAutoNum type="arabicPeriod"/>
+            </a:pPr>
+            <a:endParaRPr lang="en-US" sz="2000" dirty="0"/>
+          </a:p>
+        </p:txBody>
+      </p:sp>
+    </p:spTree>
+    <p:extLst>
+      <p:ext uri="{BB962C8B-B14F-4D97-AF65-F5344CB8AC3E}">
+        <p14:creationId xmlns:p14="http://schemas.microsoft.com/office/powerpoint/2010/main" val="1522247562"/>
+      </p:ext>
+    </p:extLst>
+  </p:cSld>
+  <p:clrMapOvr>
+    <a:masterClrMapping/>
+  </p:clrMapOvr>
+</p:sld>
+</file>
+
+<file path=ppt/slides/slide7.xml><?xml version="1.0" encoding="utf-8"?>
+<p:sld xmlns:a="http://schemas.openxmlformats.org/drawingml/2006/main" xmlns:r="http://schemas.openxmlformats.org/officeDocument/2006/relationships" xmlns:p="http://schemas.openxmlformats.org/presentationml/2006/main">
+  <p:cSld>
+    <p:spTree>
+      <p:nvGrpSpPr>
+        <p:cNvPr id="1" name="">
+          <a:extLst>
+            <a:ext uri="{FF2B5EF4-FFF2-40B4-BE49-F238E27FC236}">
+              <a16:creationId xmlns:a16="http://schemas.microsoft.com/office/drawing/2014/main" id="{F2A6E33D-EAF3-878B-A2B2-8512ECE07212}"/>
+            </a:ext>
+          </a:extLst>
+        </p:cNvPr>
+        <p:cNvGrpSpPr/>
+        <p:nvPr/>
+      </p:nvGrpSpPr>
+      <p:grpSpPr>
+        <a:xfrm>
+          <a:off x="0" y="0"/>
+          <a:ext cx="0" cy="0"/>
+          <a:chOff x="0" y="0"/>
+          <a:chExt cx="0" cy="0"/>
+        </a:xfrm>
+      </p:grpSpPr>
+      <p:sp>
+        <p:nvSpPr>
+          <p:cNvPr id="2" name="Title 1">
+            <a:extLst>
+              <a:ext uri="{FF2B5EF4-FFF2-40B4-BE49-F238E27FC236}">
+                <a16:creationId xmlns:a16="http://schemas.microsoft.com/office/drawing/2014/main" id="{2F7D14B3-B19E-7F71-3943-9C47CB3B3907}"/>
+              </a:ext>
+            </a:extLst>
+          </p:cNvPr>
+          <p:cNvSpPr>
+            <a:spLocks noGrp="1"/>
+          </p:cNvSpPr>
+          <p:nvPr>
+            <p:ph type="title"/>
+          </p:nvPr>
+        </p:nvSpPr>
+        <p:spPr/>
+        <p:txBody>
+          <a:bodyPr/>
+          <a:lstStyle/>
+          <a:p>
+            <a:r>
+              <a:rPr lang="en-US" dirty="0"/>
+              <a:t>Watch Game</a:t>
+            </a:r>
+          </a:p>
+        </p:txBody>
+      </p:sp>
+      <p:sp>
+        <p:nvSpPr>
+          <p:cNvPr id="3" name="Content Placeholder 2">
+            <a:extLst>
+              <a:ext uri="{FF2B5EF4-FFF2-40B4-BE49-F238E27FC236}">
+                <a16:creationId xmlns:a16="http://schemas.microsoft.com/office/drawing/2014/main" id="{E1D6F4BB-036B-6BFF-631C-9ECCD150CE3C}"/>
+              </a:ext>
+            </a:extLst>
+          </p:cNvPr>
+          <p:cNvSpPr>
+            <a:spLocks noGrp="1"/>
+          </p:cNvSpPr>
+          <p:nvPr>
+            <p:ph idx="1"/>
+          </p:nvPr>
+        </p:nvSpPr>
+        <p:spPr/>
+        <p:txBody>
+          <a:bodyPr>
+            <a:normAutofit/>
+          </a:bodyPr>
+          <a:lstStyle/>
+          <a:p>
+            <a:pPr marL="0" indent="0">
+              <a:buNone/>
+            </a:pPr>
+            <a:r>
+              <a:rPr lang="en-US" sz="2000" dirty="0"/>
+              <a:t>Steps</a:t>
+            </a:r>
+          </a:p>
+          <a:p>
+            <a:pPr marL="514350" indent="-514350">
+              <a:buFont typeface="+mj-lt"/>
+              <a:buAutoNum type="arabicPeriod"/>
+            </a:pPr>
+            <a:r>
+              <a:rPr lang="en-US" sz="2000" dirty="0"/>
+              <a:t>Press Play New Game button</a:t>
+            </a:r>
+          </a:p>
+          <a:p>
+            <a:pPr marL="514350" indent="-514350">
+              <a:buFont typeface="+mj-lt"/>
+              <a:buAutoNum type="arabicPeriod"/>
+            </a:pPr>
+            <a:r>
+              <a:rPr lang="en-US" sz="2000" dirty="0"/>
+              <a:t>Save Game</a:t>
+            </a:r>
+          </a:p>
+          <a:p>
+            <a:pPr marL="514350" indent="-514350">
+              <a:buFont typeface="+mj-lt"/>
+              <a:buAutoNum type="arabicPeriod"/>
+            </a:pPr>
+            <a:r>
+              <a:rPr lang="en-US" sz="2000" dirty="0"/>
+              <a:t>Browser returns to home screen</a:t>
+            </a:r>
+          </a:p>
+          <a:p>
+            <a:pPr marL="514350" indent="-514350">
+              <a:buFont typeface="+mj-lt"/>
+              <a:buAutoNum type="arabicPeriod"/>
+            </a:pPr>
+            <a:r>
+              <a:rPr lang="en-US" sz="2000" dirty="0"/>
+              <a:t>Game and correct details appear under "Your Saved Games"</a:t>
+            </a:r>
+          </a:p>
+          <a:p>
+            <a:pPr marL="0" indent="0">
+              <a:buNone/>
+            </a:pPr>
+            <a:endParaRPr lang="en-US" sz="2000" dirty="0"/>
+          </a:p>
+          <a:p>
+            <a:pPr marL="0" indent="0">
+              <a:buNone/>
+            </a:pPr>
+            <a:r>
+              <a:rPr lang="en-US" sz="2000" dirty="0"/>
+              <a:t>Components</a:t>
+            </a:r>
+          </a:p>
+          <a:p>
+            <a:pPr marL="514350" indent="-514350">
+              <a:buFont typeface="+mj-lt"/>
+              <a:buAutoNum type="alphaLcParenR"/>
+            </a:pPr>
+            <a:r>
+              <a:rPr lang="en-US" sz="2000" dirty="0" err="1"/>
+              <a:t>PlayNewGameRunContext</a:t>
+            </a:r>
+            <a:endParaRPr lang="en-US" sz="2000" dirty="0"/>
+          </a:p>
+          <a:p>
+            <a:pPr marL="514350" indent="-514350">
+              <a:buFont typeface="+mj-lt"/>
+              <a:buAutoNum type="arabicPeriod"/>
+            </a:pPr>
+            <a:endParaRPr lang="en-US" sz="2000" dirty="0"/>
+          </a:p>
+        </p:txBody>
+      </p:sp>
+    </p:spTree>
+    <p:extLst>
+      <p:ext uri="{BB962C8B-B14F-4D97-AF65-F5344CB8AC3E}">
+        <p14:creationId xmlns:p14="http://schemas.microsoft.com/office/powerpoint/2010/main" val="4120375730"/>
+      </p:ext>
+    </p:extLst>
+  </p:cSld>
+  <p:clrMapOvr>
+    <a:masterClrMapping/>
+  </p:clrMapOvr>
+</p:sld>
+</file>
+
+<file path=ppt/slides/slide8.xml><?xml version="1.0" encoding="utf-8"?>
+<p:sld xmlns:a="http://schemas.openxmlformats.org/drawingml/2006/main" xmlns:r="http://schemas.openxmlformats.org/officeDocument/2006/relationships" xmlns:p="http://schemas.openxmlformats.org/presentationml/2006/main">
+  <p:cSld>
+    <p:spTree>
+      <p:nvGrpSpPr>
+        <p:cNvPr id="1" name="">
+          <a:extLst>
+            <a:ext uri="{FF2B5EF4-FFF2-40B4-BE49-F238E27FC236}">
+              <a16:creationId xmlns:a16="http://schemas.microsoft.com/office/drawing/2014/main" id="{6FB9E1F5-4A14-557F-A50C-F617D52AC3E6}"/>
+            </a:ext>
+          </a:extLst>
+        </p:cNvPr>
+        <p:cNvGrpSpPr/>
+        <p:nvPr/>
+      </p:nvGrpSpPr>
+      <p:grpSpPr>
+        <a:xfrm>
+          <a:off x="0" y="0"/>
+          <a:ext cx="0" cy="0"/>
+          <a:chOff x="0" y="0"/>
+          <a:chExt cx="0" cy="0"/>
+        </a:xfrm>
+      </p:grpSpPr>
+      <p:sp>
+        <p:nvSpPr>
+          <p:cNvPr id="2" name="Title 1">
+            <a:extLst>
+              <a:ext uri="{FF2B5EF4-FFF2-40B4-BE49-F238E27FC236}">
+                <a16:creationId xmlns:a16="http://schemas.microsoft.com/office/drawing/2014/main" id="{0BD2CDA8-5F44-C989-CFFF-7884BBA64B98}"/>
+              </a:ext>
+            </a:extLst>
+          </p:cNvPr>
+          <p:cNvSpPr>
+            <a:spLocks noGrp="1"/>
+          </p:cNvSpPr>
+          <p:nvPr>
+            <p:ph type="title"/>
+          </p:nvPr>
+        </p:nvSpPr>
+        <p:spPr/>
+        <p:txBody>
+          <a:bodyPr/>
+          <a:lstStyle/>
+          <a:p>
+            <a:r>
+              <a:rPr lang="en-US" dirty="0"/>
+              <a:t>Delete Game</a:t>
+            </a:r>
+          </a:p>
+        </p:txBody>
+      </p:sp>
+      <p:sp>
+        <p:nvSpPr>
+          <p:cNvPr id="3" name="Content Placeholder 2">
+            <a:extLst>
+              <a:ext uri="{FF2B5EF4-FFF2-40B4-BE49-F238E27FC236}">
+                <a16:creationId xmlns:a16="http://schemas.microsoft.com/office/drawing/2014/main" id="{0028E99B-5902-6836-7246-B299DB7F15DA}"/>
+              </a:ext>
+            </a:extLst>
+          </p:cNvPr>
+          <p:cNvSpPr>
+            <a:spLocks noGrp="1"/>
+          </p:cNvSpPr>
+          <p:nvPr>
+            <p:ph idx="1"/>
+          </p:nvPr>
+        </p:nvSpPr>
+        <p:spPr/>
+        <p:txBody>
+          <a:bodyPr>
+            <a:normAutofit/>
+          </a:bodyPr>
+          <a:lstStyle/>
+          <a:p>
+            <a:pPr marL="0" indent="0">
+              <a:buNone/>
+            </a:pPr>
+            <a:r>
+              <a:rPr lang="en-US" sz="2000" dirty="0"/>
+              <a:t>Steps</a:t>
+            </a:r>
+          </a:p>
+          <a:p>
+            <a:pPr marL="514350" indent="-514350">
+              <a:buFont typeface="+mj-lt"/>
+              <a:buAutoNum type="arabicPeriod"/>
+            </a:pPr>
+            <a:r>
+              <a:rPr lang="en-US" sz="2000" dirty="0"/>
+              <a:t>Press Delete This Game</a:t>
+            </a:r>
+          </a:p>
+          <a:p>
+            <a:pPr marL="514350" indent="-514350">
+              <a:buFont typeface="+mj-lt"/>
+              <a:buAutoNum type="arabicPeriod"/>
+            </a:pPr>
+            <a:r>
+              <a:rPr lang="en-US" sz="2000" dirty="0"/>
+              <a:t>Ensure </a:t>
+            </a:r>
+            <a:r>
+              <a:rPr lang="en-US" sz="2000" dirty="0" err="1"/>
+              <a:t>SavedGames</a:t>
+            </a:r>
+            <a:r>
+              <a:rPr lang="en-US" sz="2000" dirty="0"/>
+              <a:t>, </a:t>
+            </a:r>
+            <a:r>
+              <a:rPr lang="en-US" sz="2000" dirty="0" err="1"/>
+              <a:t>SavedGameContents</a:t>
+            </a:r>
+            <a:r>
+              <a:rPr lang="en-US" sz="2000" dirty="0"/>
+              <a:t> and </a:t>
+            </a:r>
+            <a:r>
+              <a:rPr lang="en-US" sz="2000" dirty="0" err="1"/>
+              <a:t>GameRecoveries</a:t>
+            </a:r>
+            <a:r>
+              <a:rPr lang="en-US" sz="2000" dirty="0"/>
+              <a:t> tables show records deleted</a:t>
+            </a:r>
+          </a:p>
+          <a:p>
+            <a:pPr marL="0" indent="0">
+              <a:buNone/>
+            </a:pPr>
+            <a:endParaRPr lang="en-US" sz="2000" dirty="0"/>
+          </a:p>
+          <a:p>
+            <a:pPr marL="0" indent="0">
+              <a:buNone/>
+            </a:pPr>
+            <a:r>
+              <a:rPr lang="en-US" sz="2000" dirty="0"/>
+              <a:t>Components</a:t>
+            </a:r>
+          </a:p>
+          <a:p>
+            <a:pPr marL="514350" indent="-514350">
+              <a:buFont typeface="+mj-lt"/>
+              <a:buAutoNum type="alphaLcParenR"/>
+            </a:pPr>
+            <a:r>
+              <a:rPr lang="en-US" sz="2000" dirty="0" err="1"/>
+              <a:t>SqlWebPersistence.DeleteGameAsync</a:t>
+            </a:r>
+            <a:r>
+              <a:rPr lang="en-US" sz="2000" dirty="0"/>
+              <a:t> </a:t>
+            </a:r>
+          </a:p>
+          <a:p>
+            <a:pPr marL="514350" indent="-514350">
+              <a:buFont typeface="+mj-lt"/>
+              <a:buAutoNum type="arabicPeriod"/>
+            </a:pPr>
+            <a:endParaRPr lang="en-US" sz="2000" dirty="0"/>
+          </a:p>
+        </p:txBody>
+      </p:sp>
+    </p:spTree>
+    <p:extLst>
+      <p:ext uri="{BB962C8B-B14F-4D97-AF65-F5344CB8AC3E}">
+        <p14:creationId xmlns:p14="http://schemas.microsoft.com/office/powerpoint/2010/main" val="1114784947"/>
+      </p:ext>
+    </p:extLst>
+  </p:cSld>
+  <p:clrMapOvr>
+    <a:masterClrMapping/>
+  </p:clrMapOvr>
+</p:sld>
+</file>
+
+<file path=ppt/slides/slide9.xml><?xml version="1.0" encoding="utf-8"?>
+<p:sld xmlns:a="http://schemas.openxmlformats.org/drawingml/2006/main" xmlns:r="http://schemas.openxmlformats.org/officeDocument/2006/relationships" xmlns:p="http://schemas.openxmlformats.org/presentationml/2006/main">
+  <p:cSld>
+    <p:spTree>
+      <p:nvGrpSpPr>
+        <p:cNvPr id="1" name="">
+          <a:extLst>
+            <a:ext uri="{FF2B5EF4-FFF2-40B4-BE49-F238E27FC236}">
+              <a16:creationId xmlns:a16="http://schemas.microsoft.com/office/drawing/2014/main" id="{9881E30D-DF34-799A-33F5-B7A3645E8AB0}"/>
+            </a:ext>
+          </a:extLst>
+        </p:cNvPr>
+        <p:cNvGrpSpPr/>
+        <p:nvPr/>
+      </p:nvGrpSpPr>
+      <p:grpSpPr>
+        <a:xfrm>
+          <a:off x="0" y="0"/>
+          <a:ext cx="0" cy="0"/>
+          <a:chOff x="0" y="0"/>
+          <a:chExt cx="0" cy="0"/>
+        </a:xfrm>
+      </p:grpSpPr>
+      <p:sp>
+        <p:nvSpPr>
+          <p:cNvPr id="2" name="Title 1">
+            <a:extLst>
+              <a:ext uri="{FF2B5EF4-FFF2-40B4-BE49-F238E27FC236}">
+                <a16:creationId xmlns:a16="http://schemas.microsoft.com/office/drawing/2014/main" id="{F5030829-F35A-1C53-4627-62CDB21A9225}"/>
+              </a:ext>
+            </a:extLst>
+          </p:cNvPr>
+          <p:cNvSpPr>
+            <a:spLocks noGrp="1"/>
+          </p:cNvSpPr>
+          <p:nvPr>
+            <p:ph type="title"/>
+          </p:nvPr>
+        </p:nvSpPr>
+        <p:spPr/>
+        <p:txBody>
+          <a:bodyPr/>
+          <a:lstStyle/>
+          <a:p>
+            <a:r>
+              <a:rPr lang="en-US" dirty="0"/>
+              <a:t>Title</a:t>
+            </a:r>
+          </a:p>
+        </p:txBody>
+      </p:sp>
+      <p:sp>
+        <p:nvSpPr>
+          <p:cNvPr id="3" name="Content Placeholder 2">
+            <a:extLst>
+              <a:ext uri="{FF2B5EF4-FFF2-40B4-BE49-F238E27FC236}">
+                <a16:creationId xmlns:a16="http://schemas.microsoft.com/office/drawing/2014/main" id="{293E467D-684F-E96B-E2F9-F74159914F24}"/>
+              </a:ext>
+            </a:extLst>
+          </p:cNvPr>
+          <p:cNvSpPr>
+            <a:spLocks noGrp="1"/>
+          </p:cNvSpPr>
+          <p:nvPr>
+            <p:ph idx="1"/>
+          </p:nvPr>
+        </p:nvSpPr>
+        <p:spPr/>
+        <p:txBody>
+          <a:bodyPr>
+            <a:normAutofit/>
+          </a:bodyPr>
+          <a:lstStyle/>
+          <a:p>
+            <a:pPr marL="0" indent="0">
+              <a:buNone/>
+            </a:pPr>
+            <a:r>
+              <a:rPr lang="en-US" sz="2000" dirty="0"/>
+              <a:t>Steps</a:t>
+            </a:r>
+          </a:p>
+          <a:p>
+            <a:pPr marL="514350" indent="-514350">
+              <a:buFont typeface="+mj-lt"/>
+              <a:buAutoNum type="arabicPeriod"/>
+            </a:pPr>
+            <a:r>
+              <a:rPr lang="en-US" sz="2000" dirty="0"/>
+              <a:t>Step</a:t>
+            </a:r>
+          </a:p>
+          <a:p>
+            <a:pPr marL="0" indent="0">
+              <a:buNone/>
+            </a:pPr>
+            <a:endParaRPr lang="en-US" sz="2000" dirty="0"/>
+          </a:p>
+          <a:p>
+            <a:pPr marL="0" indent="0">
+              <a:buNone/>
+            </a:pPr>
+            <a:r>
+              <a:rPr lang="en-US" sz="2000" dirty="0"/>
+              <a:t>Components</a:t>
+            </a:r>
+          </a:p>
+          <a:p>
+            <a:pPr marL="514350" indent="-514350">
+              <a:buFont typeface="+mj-lt"/>
+              <a:buAutoNum type="alphaLcParenR"/>
+            </a:pPr>
+            <a:r>
+              <a:rPr lang="en-US" sz="2000" dirty="0"/>
+              <a:t>Component </a:t>
+            </a:r>
+          </a:p>
+          <a:p>
+            <a:pPr marL="514350" indent="-514350">
+              <a:buFont typeface="+mj-lt"/>
+              <a:buAutoNum type="arabicPeriod"/>
+            </a:pPr>
+            <a:endParaRPr lang="en-US" sz="2000" dirty="0"/>
+          </a:p>
+        </p:txBody>
+      </p:sp>
+    </p:spTree>
+    <p:extLst>
+      <p:ext uri="{BB962C8B-B14F-4D97-AF65-F5344CB8AC3E}">
+        <p14:creationId xmlns:p14="http://schemas.microsoft.com/office/powerpoint/2010/main" val="2028382887"/>
       </p:ext>
     </p:extLst>
   </p:cSld>

</xml_diff>